<commit_message>
Fix the Spanish title on the architecture slide
"Un ejemplo real, Arquitectura Aplicacion" had a missing accent and stacked two
nouns where the sibling slide uses a natural phrase. It now reads "Un ejemplo
real: arquitectura de la aplicación", mirroring the English fix and the sibling
"Un ejemplo real, de principio a fin".

Same shape as the English change: the six runs all carried identical formatting,
so the title collapses to one. The translations_en.py key is the Spanish line, so
it moves with it and the pair stays coherent.
</commit_message>
<xml_diff>
--- a/presentacion/Claude_Code_Presentacion.pptx
+++ b/presentacion/Claude_Code_Presentacion.pptx
@@ -46850,52 +46850,7 @@
                 </a:solidFill>
                 <a:latin typeface="Segoe UI"/>
               </a:rPr>
-              <a:t>Un </a:t>
-            </a:r>
-            <a:r>
-              <a:rPr sz="3000" b="1" dirty="0" err="1">
-                <a:solidFill>
-                  <a:srgbClr val="E8EAED"/>
-                </a:solidFill>
-                <a:latin typeface="Segoe UI"/>
-              </a:rPr>
-              <a:t>ejemplo</a:t>
-            </a:r>
-            <a:r>
-              <a:rPr sz="3000" b="1" dirty="0">
-                <a:solidFill>
-                  <a:srgbClr val="E8EAED"/>
-                </a:solidFill>
-                <a:latin typeface="Segoe UI"/>
-              </a:rPr>
-              <a:t> real, </a:t>
-            </a:r>
-            <a:r>
-              <a:rPr lang="en-GB" sz="3000" b="1" dirty="0" err="1">
-                <a:solidFill>
-                  <a:srgbClr val="E8EAED"/>
-                </a:solidFill>
-                <a:latin typeface="Segoe UI"/>
-              </a:rPr>
-              <a:t>Arquitectura</a:t>
-            </a:r>
-            <a:r>
-              <a:rPr lang="en-GB" sz="3000" b="1" dirty="0">
-                <a:solidFill>
-                  <a:srgbClr val="E8EAED"/>
-                </a:solidFill>
-                <a:latin typeface="Segoe UI"/>
-              </a:rPr>
-              <a:t> </a:t>
-            </a:r>
-            <a:r>
-              <a:rPr lang="en-GB" sz="3000" b="1" dirty="0" err="1">
-                <a:solidFill>
-                  <a:srgbClr val="E8EAED"/>
-                </a:solidFill>
-                <a:latin typeface="Segoe UI"/>
-              </a:rPr>
-              <a:t>Aplicacion</a:t>
+              <a:t>Un ejemplo real: arquitectura de la aplicación</a:t>
             </a:r>
             <a:endParaRPr sz="3000" b="1" dirty="0">
               <a:solidFill>

</xml_diff>